<commit_message>
Pitch deck: reflect organizers' GT clarification on results slide
</commit_message>
<xml_diff>
--- a/SENTINEL-Pitch-Deck.pptx
+++ b/SENTINEL-Pitch-Deck.pptx
@@ -3935,12 +3935,12 @@
               </a:spcAft>
             </a:pPr>
             <a:r>
-              <a:rPr sz="1800" b="0">
+              <a:rPr sz="1800">
                 <a:solidFill>
                   <a:srgbClr val="8FA3CC"/>
                 </a:solidFill>
               </a:rPr>
-              <a:t>No ground-truth access. Every fix came from debugging visible outputs.</a:t>
+              <a:t>Feedback loop: the official /submit endpoint · final score verified against the provided ground truth</a:t>
             </a:r>
           </a:p>
         </p:txBody>

</xml_diff>

<commit_message>
DeepSeek review round: /api/emails/{id}/recheck live AI re-decision + ⚡ button in drawer, reliability panel (escalation reasons + confidence histogram + official F1), engine column + category/low-conf filters, per-layer engine badges, README AI/Cloud sections, deck slide 5 'AI Integration & Cloud'
</commit_message>
<xml_diff>
--- a/SENTINEL-Pitch-Deck.pptx
+++ b/SENTINEL-Pitch-Deck.pptx
@@ -9,6 +9,7 @@
     <p:sldId id="257" r:id="rId8"/>
     <p:sldId id="258" r:id="rId9"/>
     <p:sldId id="259" r:id="rId10"/>
+    <p:sldId id="266" r:id="rId17"/>
     <p:sldId id="260" r:id="rId11"/>
     <p:sldId id="261" r:id="rId12"/>
     <p:sldId id="262" r:id="rId13"/>
@@ -3253,6 +3254,213 @@
                 </a:solidFill>
               </a:rPr>
               <a:t>[TEAM NAME] · Averis × Monash Hackathon 2026</a:t>
+            </a:r>
+          </a:p>
+        </p:txBody>
+      </p:sp>
+    </p:spTree>
+  </p:cSld>
+  <p:clrMapOvr>
+    <a:masterClrMapping/>
+  </p:clrMapOvr>
+</p:sld>
+</file>
+
+<file path=ppt/slides/slide11.xml><?xml version="1.0" encoding="utf-8"?>
+<p:sld xmlns:a="http://schemas.openxmlformats.org/drawingml/2006/main" xmlns:p="http://schemas.openxmlformats.org/presentationml/2006/main" xmlns:r="http://schemas.openxmlformats.org/officeDocument/2006/relationships">
+  <p:cSld>
+    <p:bg>
+      <p:bgPr>
+        <a:solidFill>
+          <a:srgbClr val="0B1020"/>
+        </a:solidFill>
+        <a:effectLst/>
+      </p:bgPr>
+    </p:bg>
+    <p:spTree>
+      <p:nvGrpSpPr>
+        <p:cNvPr id="1" name=""/>
+        <p:cNvGrpSpPr/>
+        <p:nvPr/>
+      </p:nvGrpSpPr>
+      <p:grpSpPr/>
+      <p:sp>
+        <p:nvSpPr>
+          <p:cNvPr id="2" name="TextBox 1"/>
+          <p:cNvSpPr txBox="1"/>
+          <p:nvPr/>
+        </p:nvSpPr>
+        <p:spPr>
+          <a:xfrm>
+            <a:off x="548640" y="320040"/>
+            <a:ext cx="11064240" cy="914400"/>
+          </a:xfrm>
+          <a:prstGeom prst="rect">
+            <a:avLst/>
+          </a:prstGeom>
+          <a:noFill/>
+        </p:spPr>
+        <p:txBody>
+          <a:bodyPr wrap="square">
+            <a:spAutoFit/>
+          </a:bodyPr>
+          <a:lstStyle/>
+          <a:p>
+            <a:r>
+              <a:rPr sz="3200" b="1">
+                <a:solidFill>
+                  <a:srgbClr val="4DA3FF"/>
+                </a:solidFill>
+              </a:rPr>
+              <a:t>AI Integration &amp; Cloud — verifiable, not promised</a:t>
+            </a:r>
+          </a:p>
+        </p:txBody>
+      </p:sp>
+      <p:sp>
+        <p:nvSpPr>
+          <p:cNvPr id="3" name="TextBox 2"/>
+          <p:cNvSpPr txBox="1"/>
+          <p:nvPr/>
+        </p:nvSpPr>
+        <p:spPr>
+          <a:xfrm>
+            <a:off x="822960" y="1463040"/>
+            <a:ext cx="10607040" cy="4937760"/>
+          </a:xfrm>
+          <a:prstGeom prst="rect">
+            <a:avLst/>
+          </a:prstGeom>
+          <a:noFill/>
+        </p:spPr>
+        <p:txBody>
+          <a:bodyPr wrap="square">
+            <a:spAutoFit/>
+          </a:bodyPr>
+          <a:lstStyle/>
+          <a:p>
+            <a:r>
+              <a:rPr sz="1900" b="1">
+                <a:solidFill>
+                  <a:srgbClr val="F5B08C"/>
+                </a:solidFill>
+              </a:rPr>
+              <a:t>▪ Every layer shows its engine</a:t>
+            </a:r>
+          </a:p>
+          <a:p>
+            <a:pPr>
+              <a:spcAft>
+                <a:spcPts val="1000"/>
+              </a:spcAft>
+            </a:pPr>
+            <a:r>
+              <a:rPr sz="1550">
+                <a:solidFill>
+                  <a:srgbClr val="E8EEFF"/>
+                </a:solidFill>
+              </a:rPr>
+              <a:t>Pipeline view badges each layer: rules / LLM / hybrid — the backend is visible, not claimed.</a:t>
+            </a:r>
+          </a:p>
+          <a:p>
+            <a:r>
+              <a:rPr sz="1900" b="1">
+                <a:solidFill>
+                  <a:srgbClr val="F5B08C"/>
+                </a:solidFill>
+              </a:rPr>
+              <a:t>▪ ⚡ “Re-decide with AI” on any email</a:t>
+            </a:r>
+          </a:p>
+          <a:p>
+            <a:pPr>
+              <a:spcAft>
+                <a:spcPts val="1000"/>
+              </a:spcAft>
+            </a:pPr>
+            <a:r>
+              <a:rPr sz="1550">
+                <a:solidFill>
+                  <a:srgbClr val="E8EEFF"/>
+                </a:solidFill>
+              </a:rPr>
+              <a:t>One click re-runs the full path with the LLM forced: engine flips rules → llm+rules, the court convenes, the verdict is confirmed live (email_313: 5≠4 containers, ±500 kg — re-found by AI).</a:t>
+            </a:r>
+          </a:p>
+          <a:p>
+            <a:r>
+              <a:rPr sz="1900" b="1">
+                <a:solidFill>
+                  <a:srgbClr val="F5B08C"/>
+                </a:solidFill>
+              </a:rPr>
+              <a:t>▪ Generalize Lab</a:t>
+            </a:r>
+          </a:p>
+          <a:p>
+            <a:pPr>
+              <a:spcAft>
+                <a:spcPts val="1000"/>
+              </a:spcAft>
+            </a:pPr>
+            <a:r>
+              <a:rPr sz="1550">
+                <a:solidFill>
+                  <a:srgbClr val="E8EEFF"/>
+                </a:solidFill>
+              </a:rPr>
+              <a:t>Paste an email that is not in the dataset — the AI path classifies, extracts and compares it end-to-end.</a:t>
+            </a:r>
+          </a:p>
+          <a:p>
+            <a:r>
+              <a:rPr sz="1900" b="1">
+                <a:solidFill>
+                  <a:srgbClr val="F5B08C"/>
+                </a:solidFill>
+              </a:rPr>
+              <a:t>▪ Graceful degradation</a:t>
+            </a:r>
+          </a:p>
+          <a:p>
+            <a:pPr>
+              <a:spcAft>
+                <a:spcPts val="1000"/>
+              </a:spcAft>
+            </a:pPr>
+            <a:r>
+              <a:rPr sz="1550">
+                <a:solidFill>
+                  <a:srgbClr val="E8EEFF"/>
+                </a:solidFill>
+              </a:rPr>
+              <a:t>Quota or provider down → deterministic engine takes over and returns the same verdict. Resilience by design.</a:t>
+            </a:r>
+          </a:p>
+          <a:p>
+            <a:r>
+              <a:rPr sz="1900" b="1">
+                <a:solidFill>
+                  <a:srgbClr val="F5B08C"/>
+                </a:solidFill>
+              </a:rPr>
+              <a:t>▪ Live on Render (Blueprint, autodeploy)</a:t>
+            </a:r>
+          </a:p>
+          <a:p>
+            <a:pPr>
+              <a:spcAft>
+                <a:spcPts val="1000"/>
+              </a:spcAft>
+            </a:pPr>
+            <a:r>
+              <a:rPr sz="1550">
+                <a:solidFill>
+                  <a:srgbClr val="E8EEFF"/>
+                </a:solidFill>
+              </a:rPr>
+              <a:t>https://sentinel-sdoc.onrender.com — /api/health: 520 emails · gemini:gemini-flash-latest</a:t>
             </a:r>
           </a:p>
         </p:txBody>

</xml_diff>